<commit_message>
Translate UI VLM GPU proposal deck to Korean
</commit_message>
<xml_diff>
--- a/docs/ui_vlm_dedicated_gpu_argument.pptx
+++ b/docs/ui_vlm_dedicated_gpu_argument.pptx
@@ -3121,7 +3121,7 @@
               </a:defRPr>
             </a:pPr>
             <a:r>
-              <a:t>Why We Need a Dedicated Local GPU for UI-Specialized VLMs</a:t>
+              <a:t>복잡 UI 대응을 위한 독립 GPU 필요성</a:t>
             </a:r>
           </a:p>
         </p:txBody>
@@ -3156,7 +3156,7 @@
               </a:defRPr>
             </a:pPr>
             <a:r>
-              <a:t>CD-SEM/VeritySEM automation: current VLM struggles with dense, ambiguous UI elements</a:t>
+              <a:t>CD-SEM/VeritySEM 자동화: 현재 VLM은 복잡한 UI 요소 해석에서 한계가 확인됨</a:t>
             </a:r>
           </a:p>
         </p:txBody>
@@ -3234,7 +3234,7 @@
               </a:defRPr>
             </a:pPr>
             <a:r>
-              <a:t>Observed issue: current general VLM often misses fine-grained UI components (nested panes, tiny icons, similar controls).</a:t>
+              <a:t>관찰된 문제: 현재 범용 VLM은 중첩 패널, 작은 아이콘, 유사 컨트롤 구분에서 오인식이 잦음.</a:t>
             </a:r>
           </a:p>
           <a:p>
@@ -3246,7 +3246,7 @@
               </a:defRPr>
             </a:pPr>
             <a:r>
-              <a:t>Consequence: repeated correction loops, unstable click targets, and slower recipe creation throughput.</a:t>
+              <a:t>영향: 클릭 재시도 증가, 단계 실패 누적, 레시피 생성 리드타임 증가.</a:t>
             </a:r>
           </a:p>
           <a:p>
@@ -3258,7 +3258,7 @@
               </a:defRPr>
             </a:pPr>
             <a:r>
-              <a:t>Decision: run a UI-strong VLM locally on dedicated GPU to improve visual grounding, response time, and data control.</a:t>
+              <a:t>결론: UI 특화 로컬 VLM을 독립 GPU에서 상시 구동해 정확도·지연시간·재현성을 동시에 개선해야 함.</a:t>
             </a:r>
           </a:p>
         </p:txBody>
@@ -3312,7 +3312,7 @@
               </a:defRPr>
             </a:pPr>
             <a:r>
-              <a:t>Bottom line: for complicated industrial UI, model quality + local latency matter more than raw token price.</a:t>
+              <a:t>핵심: 산업용 복잡 UI 자동화에서는 모델 품질과 로컬 응답성이 비용보다 우선됨</a:t>
             </a:r>
           </a:p>
         </p:txBody>
@@ -3365,7 +3365,7 @@
               </a:defRPr>
             </a:pPr>
             <a:r>
-              <a:t>SOTA VLMs for UI Understanding (as of Feb 25, 2026)</a:t>
+              <a:t>UI 이해 특화 SOTA VLM 비교 (2026-02-25 기준)</a:t>
             </a:r>
           </a:p>
         </p:txBody>
@@ -3400,7 +3400,7 @@
               </a:defRPr>
             </a:pPr>
             <a:r>
-              <a:t>Higher is better. N/A means no public score in official model docs.</a:t>
+              <a:t>값이 높을수록 우수. N/A는 공식 문서상 미공개</a:t>
             </a:r>
           </a:p>
         </p:txBody>
@@ -3445,7 +3445,7 @@
                         </a:defRPr>
                       </a:pPr>
                       <a:r>
-                        <a:t>Model</a:t>
+                        <a:t>모델</a:t>
                       </a:r>
                     </a:p>
                   </a:txBody>
@@ -3537,7 +3537,7 @@
                         </a:defRPr>
                       </a:pPr>
                       <a:r>
-                        <a:t>Adoption signal</a:t>
+                        <a:t>활용 신호</a:t>
                       </a:r>
                     </a:p>
                   </a:txBody>
@@ -3560,7 +3560,7 @@
                         </a:defRPr>
                       </a:pPr>
                       <a:r>
-                        <a:t>Notes</a:t>
+                        <a:t>요약</a:t>
                       </a:r>
                     </a:p>
                   </a:txBody>
@@ -3673,7 +3673,7 @@
                         </a:defRPr>
                       </a:pPr>
                       <a:r>
-                        <a:t>1.79M downloads/mo</a:t>
+                        <a:t>월 179만 다운로드</a:t>
                       </a:r>
                     </a:p>
                   </a:txBody>
@@ -3692,7 +3692,7 @@
                         </a:defRPr>
                       </a:pPr>
                       <a:r>
-                        <a:t>Strong open model; widely used baseline for GUI agents.</a:t>
+                        <a:t>오픈 모델 중 GUI 에이전트 기본선으로 널리 사용</a:t>
                       </a:r>
                     </a:p>
                   </a:txBody>
@@ -3801,7 +3801,7 @@
                         </a:defRPr>
                       </a:pPr>
                       <a:r>
-                        <a:t>9.7k GitHub stars</a:t>
+                        <a:t>GitHub 9.7k stars</a:t>
                       </a:r>
                     </a:p>
                   </a:txBody>
@@ -3820,7 +3820,7 @@
                         </a:defRPr>
                       </a:pPr>
                       <a:r>
-                        <a:t>Purpose-built UI agent model; strong action grounding.</a:t>
+                        <a:t>UI 에이전트 목적 특화, 액션 grounding 강점</a:t>
                       </a:r>
                     </a:p>
                   </a:txBody>
@@ -3929,7 +3929,7 @@
                         </a:defRPr>
                       </a:pPr>
                       <a:r>
-                        <a:t>GroundCUA repo</a:t>
+                        <a:t>GroundCUA 공식 공개</a:t>
                       </a:r>
                     </a:p>
                   </a:txBody>
@@ -3948,7 +3948,7 @@
                         </a:defRPr>
                       </a:pPr>
                       <a:r>
-                        <a:t>Grounding-focused; strong OSWorld-G generalization.</a:t>
+                        <a:t>grounding 중심, OSWorld-G 일반화 강함</a:t>
                       </a:r>
                     </a:p>
                   </a:txBody>
@@ -4057,7 +4057,7 @@
                         </a:defRPr>
                       </a:pPr>
                       <a:r>
-                        <a:t>Open model card</a:t>
+                        <a:t>공식 모델 카드</a:t>
                       </a:r>
                     </a:p>
                   </a:txBody>
@@ -4076,7 +4076,7 @@
                         </a:defRPr>
                       </a:pPr>
                       <a:r>
-                        <a:t>Best published open UI benchmark among listed models.</a:t>
+                        <a:t>공개 지표 기준 상위권 UI 성능</a:t>
                       </a:r>
                     </a:p>
                   </a:txBody>
@@ -4185,7 +4185,7 @@
                         </a:defRPr>
                       </a:pPr>
                       <a:r>
-                        <a:t>Open model card</a:t>
+                        <a:t>공식 모델 카드</a:t>
                       </a:r>
                     </a:p>
                   </a:txBody>
@@ -4204,7 +4204,7 @@
                         </a:defRPr>
                       </a:pPr>
                       <a:r>
-                        <a:t>Top score with iterative refinement pipeline.</a:t>
+                        <a:t>반복 정제 파이프라인 포함 시 최고 점수</a:t>
                       </a:r>
                     </a:p>
                   </a:txBody>
@@ -4313,7 +4313,7 @@
                         </a:defRPr>
                       </a:pPr>
                       <a:r>
-                        <a:t>1.38M downloads/mo</a:t>
+                        <a:t>월 138만 다운로드</a:t>
                       </a:r>
                     </a:p>
                   </a:txBody>
@@ -4332,7 +4332,7 @@
                         </a:defRPr>
                       </a:pPr>
                       <a:r>
-                        <a:t>Frontier multimodal model; no public ScreenSpot/OSWorld in official card.</a:t>
+                        <a:t>프런티어 멀티모달 모델, UI 벤치마크 공개치 부재</a:t>
                       </a:r>
                     </a:p>
                   </a:txBody>
@@ -4373,7 +4373,7 @@
               </a:defRPr>
             </a:pPr>
             <a:r>
-              <a:t>Sources: Qwen official model card (Qwen/Qwen3-VL-30B-A3B-Instruct), UI-TARS official GitHub README, GroundCUA official README,</a:t>
+              <a:t>출처: Qwen 공식 모델 카드(Qwen/Qwen3-VL-30B-A3B-Instruct), UI-TARS 공식 GitHub README, GroundCUA README,</a:t>
             </a:r>
           </a:p>
           <a:p>
@@ -4385,7 +4385,7 @@
               </a:defRPr>
             </a:pPr>
             <a:r>
-              <a:t>Gelato model card (ServiceNow-AI/Gelato-30B-A3B), Kimi official model card (moonshotai/Kimi-K2.5-Instruct).</a:t>
+              <a:t>Gelato 모델 카드(ServiceNow-AI/Gelato-30B-A3B), Kimi 공식 모델 카드(moonshotai/Kimi-K2.5-Instruct).</a:t>
             </a:r>
           </a:p>
           <a:p>
@@ -4397,7 +4397,7 @@
               </a:defRPr>
             </a:pPr>
             <a:r>
-              <a:t>Note: OSWorld and OSWorld-G are different benchmarks; compare within the same column only.</a:t>
+              <a:t>주의: OSWorld와 OSWorld-G는 다른 벤치마크이므로 동일 열 내에서만 비교 필요.</a:t>
             </a:r>
           </a:p>
         </p:txBody>
@@ -4450,7 +4450,7 @@
               </a:defRPr>
             </a:pPr>
             <a:r>
-              <a:t>Recommendation: Dedicated Local GPU for Stable UI Automation</a:t>
+              <a:t>권고안: UI 자동화 안정화를 위한 독립 GPU 도입</a:t>
             </a:r>
           </a:p>
         </p:txBody>
@@ -4485,7 +4485,7 @@
               </a:defRPr>
             </a:pPr>
             <a:r>
-              <a:t>Deploy a UI-specialized local model as default, keep cloud/frontier model as fallback.</a:t>
+              <a:t>기본은 로컬 UI 특화 모델, 난이도 높은 케이스만 프런티어 모델로 라우팅</a:t>
             </a:r>
           </a:p>
         </p:txBody>
@@ -4520,7 +4520,7 @@
               </a:defRPr>
             </a:pPr>
             <a:r>
-              <a:t>1) Default local model: UI-TARS-1.5-7B or Qwen3-VL-30B (quantized) for real-time UI grounding.</a:t>
+              <a:t>1) 기본 로컬 모델: UI-TARS-1.5-7B 또는 Qwen3-VL-30B(양자화) 상시 운용</a:t>
             </a:r>
           </a:p>
           <a:p>
@@ -4532,7 +4532,7 @@
               </a:defRPr>
             </a:pPr>
             <a:r>
-              <a:t>2) Fallback routing: escalate hard/ambiguous screens to larger model (e.g., Kimi-K2.5) only when needed.</a:t>
+              <a:t>2) 예외 라우팅: 난해/모호 화면만 Kimi-K2.5급 모델로 업스케일</a:t>
             </a:r>
           </a:p>
           <a:p>
@@ -4544,7 +4544,7 @@
               </a:defRPr>
             </a:pPr>
             <a:r>
-              <a:t>3) Expected gain: fewer mis-click retries, faster step completion, better reproducibility and auditability.</a:t>
+              <a:t>3) 기대효과: 오클릭 재시도 감소, 단계 완료 시간 단축, 재현성과 감사 용이성 향상</a:t>
             </a:r>
           </a:p>
         </p:txBody>
@@ -4586,7 +4586,7 @@
                         </a:defRPr>
                       </a:pPr>
                       <a:r>
-                        <a:t>Tier</a:t>
+                        <a:t>단계</a:t>
                       </a:r>
                     </a:p>
                   </a:txBody>
@@ -4609,7 +4609,7 @@
                         </a:defRPr>
                       </a:pPr>
                       <a:r>
-                        <a:t>Target model class</a:t>
+                        <a:t>권장 모델군</a:t>
                       </a:r>
                     </a:p>
                   </a:txBody>
@@ -4632,7 +4632,7 @@
                         </a:defRPr>
                       </a:pPr>
                       <a:r>
-                        <a:t>GPU guidance</a:t>
+                        <a:t>GPU 가이드</a:t>
                       </a:r>
                     </a:p>
                   </a:txBody>
@@ -4657,7 +4657,7 @@
                         </a:defRPr>
                       </a:pPr>
                       <a:r>
-                        <a:t>Pilot</a:t>
+                        <a:t>파일럿</a:t>
                       </a:r>
                     </a:p>
                   </a:txBody>
@@ -4676,7 +4676,7 @@
                         </a:defRPr>
                       </a:pPr>
                       <a:r>
-                        <a:t>7B UI models</a:t>
+                        <a:t>7B UI 특화 모델</a:t>
                       </a:r>
                     </a:p>
                   </a:txBody>
@@ -4695,7 +4695,7 @@
                         </a:defRPr>
                       </a:pPr>
                       <a:r>
-                        <a:t>Single GPU (&gt;=24GB VRAM)</a:t>
+                        <a:t>단일 GPU (VRAM 24GB 이상)</a:t>
                       </a:r>
                     </a:p>
                   </a:txBody>
@@ -4716,7 +4716,7 @@
                         </a:defRPr>
                       </a:pPr>
                       <a:r>
-                        <a:t>Production</a:t>
+                        <a:t>프로덕션</a:t>
                       </a:r>
                     </a:p>
                   </a:txBody>
@@ -4754,7 +4754,7 @@
                         </a:defRPr>
                       </a:pPr>
                       <a:r>
-                        <a:t>Dedicated GPU (&gt;=48GB VRAM)</a:t>
+                        <a:t>독립 GPU (VRAM 48GB 이상)</a:t>
                       </a:r>
                     </a:p>
                   </a:txBody>
@@ -4775,7 +4775,7 @@
                         </a:defRPr>
                       </a:pPr>
                       <a:r>
-                        <a:t>Frontier fallback</a:t>
+                        <a:t>프런티어 보조</a:t>
                       </a:r>
                     </a:p>
                   </a:txBody>
@@ -4794,7 +4794,7 @@
                         </a:defRPr>
                       </a:pPr>
                       <a:r>
-                        <a:t>Kimi-K2.5 class</a:t>
+                        <a:t>Kimi-K2.5급</a:t>
                       </a:r>
                     </a:p>
                   </a:txBody>
@@ -4813,7 +4813,7 @@
                         </a:defRPr>
                       </a:pPr>
                       <a:r>
-                        <a:t>Multi-GPU node (official guide: TP8 H200)</a:t>
+                        <a:t>멀티 GPU 노드 (공식 예시: TP8 H200)</a:t>
                       </a:r>
                     </a:p>
                   </a:txBody>
@@ -4873,7 +4873,7 @@
               </a:defRPr>
             </a:pPr>
             <a:r>
-              <a:t>Ask: approve independent GPU budget so we can run UI-specialized local VLM as primary engine.</a:t>
+              <a:t>요청사항: UI 특화 로컬 VLM 상시 구동을 위한 독립 GPU 예산 승인</a:t>
             </a:r>
           </a:p>
         </p:txBody>
@@ -4908,7 +4908,7 @@
               </a:defRPr>
             </a:pPr>
             <a:r>
-              <a:t>Source for frontier deployment: moonshotai/Kimi-K2.5 Deployment Guide (TP8 H200 example).</a:t>
+              <a:t>프런티어 배치 근거: moonshotai/Kimi-K2.5 Deployment Guide (TP8 H200 예시).</a:t>
             </a:r>
           </a:p>
         </p:txBody>
@@ -4961,7 +4961,7 @@
               </a:defRPr>
             </a:pPr>
             <a:r>
-              <a:t>OmniParser: Can It Be Used with UI-Specialized Models?</a:t>
+              <a:t>OmniParser 병행 활용 방안</a:t>
             </a:r>
           </a:p>
         </p:txBody>
@@ -4996,7 +4996,7 @@
               </a:defRPr>
             </a:pPr>
             <a:r>
-              <a:t>Yes. Use OmniParser as the perception layer, then route actions to your UI-specialized VLM.</a:t>
+              <a:t>가능함: OmniParser를 인지 계층으로 두고 UI 특화 VLM과 결합</a:t>
             </a:r>
           </a:p>
         </p:txBody>
@@ -5050,7 +5050,7 @@
               </a:defRPr>
             </a:pPr>
             <a:r>
-              <a:t>What OmniParser does</a:t>
+              <a:t>OmniParser가 하는 일</a:t>
             </a:r>
           </a:p>
           <a:p>
@@ -5062,7 +5062,7 @@
               </a:defRPr>
             </a:pPr>
             <a:r>
-              <a:t>• Converts screenshot into structured, actionable UI elements.</a:t>
+              <a:t>• 스크린샷을 구조화된 UI 요소 목록으로 변환</a:t>
             </a:r>
           </a:p>
           <a:p>
@@ -5074,7 +5074,7 @@
               </a:defRPr>
             </a:pPr>
             <a:r>
-              <a:t>• Detects interactable regions and captions icons.</a:t>
+              <a:t>• 인터랙션 가능한 영역 검출 + 아이콘 의미 캡셔닝</a:t>
             </a:r>
           </a:p>
           <a:p>
@@ -5086,7 +5086,7 @@
               </a:defRPr>
             </a:pPr>
             <a:r>
-              <a:t>• Improves grounding for models that struggle with tiny/ambiguous controls.</a:t>
+              <a:t>• 작은/모호한 컨트롤에서 모델 grounding 보강</a:t>
             </a:r>
           </a:p>
           <a:p>
@@ -5098,7 +5098,7 @@
               </a:defRPr>
             </a:pPr>
             <a:r>
-              <a:t>• Reported gain: GPT-4o on ScreenSpot Pro 39.6 -&gt; 52.1.</a:t>
+              <a:t>• 공개 보고치: GPT-4o ScreenSpot Pro 39.6 -&gt; 52.1</a:t>
             </a:r>
           </a:p>
         </p:txBody>
@@ -5152,7 +5152,7 @@
               </a:defRPr>
             </a:pPr>
             <a:r>
-              <a:t>Officially shown compatible (OmniTool)</a:t>
+              <a:t>공식 호환(OmniTool 공개 예시)</a:t>
             </a:r>
           </a:p>
           <a:p>
@@ -5176,7 +5176,7 @@
               </a:defRPr>
             </a:pPr>
             <a:r>
-              <a:t>• DeepSeek-R1 (via OpenRouter)</a:t>
+              <a:t>• DeepSeek-R1 (OpenRouter 경유)</a:t>
             </a:r>
           </a:p>
           <a:p>
@@ -5188,7 +5188,7 @@
               </a:defRPr>
             </a:pPr>
             <a:r>
-              <a:t>• Qwen2.5-VL series</a:t>
+              <a:t>• Qwen2.5-VL 계열</a:t>
             </a:r>
           </a:p>
           <a:p>
@@ -5212,7 +5212,7 @@
               </a:defRPr>
             </a:pPr>
             <a:r>
-              <a:t>• Plus local model endpoints through adapter APIs</a:t>
+              <a:t>• 로컬 API 어댑터를 통한 자체 모델 연동 가능</a:t>
             </a:r>
           </a:p>
         </p:txBody>
@@ -5266,7 +5266,7 @@
               </a:defRPr>
             </a:pPr>
             <a:r>
-              <a:t>Recommended stack for your case</a:t>
+              <a:t>권장 아키텍처</a:t>
             </a:r>
           </a:p>
           <a:p>
@@ -5278,7 +5278,7 @@
               </a:defRPr>
             </a:pPr>
             <a:r>
-              <a:t>Capture -&gt; OmniParser (element map) -&gt; UI-specialized VLM (Qwen3-VL/UI-TARS/GroundNext) -&gt; Action executor -&gt; Verifier</a:t>
+              <a:t>Capture -&gt; OmniParser(요소 맵) -&gt; UI 특화 VLM(Qwen3-VL/UI-TARS/GroundNext) -&gt; Action Executor -&gt; Verifier</a:t>
             </a:r>
           </a:p>
           <a:p>
@@ -5290,7 +5290,7 @@
               </a:defRPr>
             </a:pPr>
             <a:r>
-              <a:t>Inference: this hybrid design typically reduces coordinate hallucination and retry loops in complex industrial UI.</a:t>
+              <a:t>실무 효과: 좌표 환각(hallucination)과 재시도 루프를 줄여 복잡 UI 자동화 안정성 개선</a:t>
             </a:r>
           </a:p>
         </p:txBody>
@@ -5325,7 +5325,7 @@
               </a:defRPr>
             </a:pPr>
             <a:r>
-              <a:t>Sources: microsoft/OmniParser README + arXiv 2408.00203; compatibility list from OmniTool section in official repo.</a:t>
+              <a:t>출처: microsoft/OmniParser README, arXiv 2408.00203, OmniTool 호환 모델 목록</a:t>
             </a:r>
           </a:p>
         </p:txBody>

</xml_diff>